<commit_message>
Professional flow timings: canvas 25-30 min, solution canvas 5-10 min
Co-Authored-By: Claude Fable 5.1 <noreply@anthropic.com>
Claude-Session: https://claude.ai/code/session_01P7o6S9R44PVqU2edRj877h
</commit_message>
<xml_diff>
--- a/docs/SkillAIbility_WP3_Workshop_Procedure.pptx
+++ b/docs/SkillAIbility_WP3_Workshop_Procedure.pptx
@@ -3272,7 +3272,7 @@
                 <a:ea typeface="Calibri" pitchFamily="34" charset="-122"/>
                 <a:cs typeface="Calibri" pitchFamily="34" charset="-120"/>
               </a:rPr>
-              <a:t>About 90 minutes including introduction and wrap-up. Adjust to your slot.</a:t>
+              <a:t>About 95 minutes including introduction and wrap-up. Adjust to your slot.</a:t>
             </a:r>
             <a:endParaRPr lang="en-US" sz="1500" dirty="0"/>
           </a:p>
@@ -3626,7 +3626,7 @@
                 <a:ea typeface="Calibri" pitchFamily="34" charset="-122"/>
                 <a:cs typeface="Calibri" pitchFamily="34" charset="-120"/>
               </a:rPr>
-              <a:t>25–45 min</a:t>
+              <a:t>25–55 min</a:t>
             </a:r>
             <a:endParaRPr lang="en-US" sz="1350" dirty="0"/>
           </a:p>
@@ -3770,7 +3770,7 @@
                 <a:ea typeface="Calibri" pitchFamily="34" charset="-122"/>
                 <a:cs typeface="Calibri" pitchFamily="34" charset="-120"/>
               </a:rPr>
-              <a:t>45–75 min</a:t>
+              <a:t>55–85 min</a:t>
             </a:r>
             <a:endParaRPr lang="en-US" sz="1350" dirty="0"/>
           </a:p>
@@ -3914,7 +3914,7 @@
                 <a:ea typeface="Calibri" pitchFamily="34" charset="-122"/>
                 <a:cs typeface="Calibri" pitchFamily="34" charset="-120"/>
               </a:rPr>
-              <a:t>75–90 min</a:t>
+              <a:t>85–95 min</a:t>
             </a:r>
             <a:endParaRPr lang="en-US" sz="1350" dirty="0"/>
           </a:p>
@@ -4058,7 +4058,7 @@
                 <a:ea typeface="Calibri" pitchFamily="34" charset="-122"/>
                 <a:cs typeface="Calibri" pitchFamily="34" charset="-120"/>
               </a:rPr>
-              <a:t>90+ min</a:t>
+              <a:t>95+ min</a:t>
             </a:r>
             <a:endParaRPr lang="en-US" sz="1350" dirty="0"/>
           </a:p>
@@ -7123,7 +7123,7 @@
                 <a:ea typeface="Calibri" pitchFamily="34" charset="-122"/>
                 <a:cs typeface="Calibri" pitchFamily="34" charset="-120"/>
               </a:rPr>
-              <a:t>for scholars · 4 steps · 70–95 min</a:t>
+              <a:t>for scholars · 4 steps · 65–90 min</a:t>
             </a:r>
             <a:endParaRPr lang="en-US" sz="1150" dirty="0"/>
           </a:p>
@@ -8905,7 +8905,7 @@
                 <a:ea typeface="Calibri" pitchFamily="34" charset="-122"/>
                 <a:cs typeface="Calibri" pitchFamily="34" charset="-120"/>
               </a:rPr>
-              <a:t>⏱ 15–20 min</a:t>
+              <a:t>⏱ 25–30 min</a:t>
             </a:r>
             <a:endParaRPr lang="en-US" sz="1300" dirty="0"/>
           </a:p>
@@ -10064,7 +10064,7 @@
                 <a:ea typeface="Calibri" pitchFamily="34" charset="-122"/>
                 <a:cs typeface="Calibri" pitchFamily="34" charset="-120"/>
               </a:rPr>
-              <a:t>⏱ 20–25 min</a:t>
+              <a:t>⏱ 5–10 min</a:t>
             </a:r>
             <a:endParaRPr lang="en-US" sz="1300" dirty="0"/>
           </a:p>

</xml_diff>

<commit_message>
Academic Version / Industrial Version (capital V)
Co-Authored-By: Claude Fable 5.1 <noreply@anthropic.com>
Claude-Session: https://claude.ai/code/session_01P7o6S9R44PVqU2edRj877h
</commit_message>
<xml_diff>
--- a/docs/SkillAIbility_WP3_Workshop_Procedure.pptx
+++ b/docs/SkillAIbility_WP3_Workshop_Procedure.pptx
@@ -12239,7 +12239,7 @@
                   <a:srgbClr val="0B1138"/>
                 </a:solidFill>
               </a:rPr>
-              <a:t>Industrial version</a:t>
+              <a:t>Industrial Version</a:t>
             </a:r>
           </a:p>
         </p:txBody>
@@ -12454,7 +12454,7 @@
                   <a:srgbClr val="FFFFFF"/>
                 </a:solidFill>
               </a:rPr>
-              <a:t>Academic version</a:t>
+              <a:t>Academic Version</a:t>
             </a:r>
           </a:p>
         </p:txBody>

</xml_diff>